<commit_message>
Part B 重大重建: 换订正数据底 + best-of-both按日 + 全shapefile + 清理
数据订正(旧 Tourist/TOTAL 队友确认做错,已删):
- 改用 background_od + total_new_project_flow_internal_only(PROJECT)
- 净增量 = PROJECT-background = 960万(+9.7%); best-of-both 按日(增量÷20赛事日)
- 弃用被本底污染的 event/non_event 日矩阵(保留作证据链)
- 修正分区语义: 火车站=zone79(并入L1走廊), zone1=Centro Direzionale

新结果: L1 0.71→0.91(60%破1.09,走廊级1.20) binding constraint; L2 0.70/L6 0.65/Cumana 0.51

产出(全部重建+一致): 5脚本 + 5图(全shapefile真实地图,无散点) + 方法论 + 答辩话术
+ docx(5图+正文) + pptx(图+文字+演讲备注) + B_zone_metrics.csv + CLAUDE.md

清理: 删旧Part A图chart1-6 + 散点/冗余图 + 做错的旧矩阵

Co-Authored-By: Claude Opus 4.8 <noreply@anthropic.com>
</commit_message>
<xml_diff>
--- a/5.11 fjy/PartB_slides.pptx
+++ b/5.11 fjy/PartB_slides.pptx
@@ -504,7 +504,7 @@
           <a:lstStyle/>
           <a:p>
             <a:r>
-              <a:t>Not a total-capacity problem, a distribution problem. Bagnoli venue has 3 lines and spare capacity, but Metro Line 1 — central spine through Napoli Centrale — is the binding constraint: 0.69 to 0.84, over 1.0 if transit share reaches 60%.</a:t>
+              <a:t>Not a total-capacity problem, a distribution problem. Bagnoli venue has 3 lines and spare capacity, but Metro Line 1 — central spine through Napoli Centrale — is the binding constraint: 0.71 to 0.91 on an event day, over 1.0 at 60% transit share or under corridor concentration (1.20).</a:t>
             </a:r>
           </a:p>
         </p:txBody>
@@ -644,7 +644,7 @@
           <a:lstStyle/>
           <a:p>
             <a:r>
-              <a:t>OSRM accessibility: 73% within a 45-min drive — Naples-centred, why the central corridor takes the pressure. ~20% from beyond 60 min leans on regional rail. Conclusion: distribution problem, not shortfall — target Line 1 and the gateway. Mitigation (shuttle bus) is the Services-improvement part.</a:t>
+              <a:t>OSRM accessibility: 71% within a 45-min drive (mean 41 min) — Naples-centred, why the central corridor takes the pressure. ~21% from beyond 60 min leans on regional rail. Conclusion: distribution problem, not shortfall — target Line 1 and the gateway. Mitigation (shuttle bus) is the Services-improvement part.</a:t>
             </a:r>
           </a:p>
         </p:txBody>
@@ -3737,7 +3737,7 @@
             </a:pPr>
             <a:r>
               <a:rPr sz="1600" b="0"/>
-              <a:t>• Metro Line 1 is the binding constraint: 0.69 → 0.84 at peak, &gt;1.0 if transit share hits 60%.</a:t>
+              <a:t>• Metro Line 1 is the binding constraint: 0.71 → 0.91 at peak (event day), &gt;1.0 at 60% transit share or under corridor concentration (1.20).</a:t>
             </a:r>
           </a:p>
           <a:p>
@@ -3763,7 +3763,7 @@
             </a:pPr>
             <a:r>
               <a:rPr sz="1600" b="0"/>
-              <a:t>• Region-wide  +11%</a:t>
+              <a:t>• Region-wide  +9.7%</a:t>
             </a:r>
           </a:p>
           <a:p>
@@ -3774,7 +3774,7 @@
             </a:pPr>
             <a:r>
               <a:rPr sz="1600" b="0"/>
-              <a:t>• Central event zones  +23%</a:t>
+              <a:t>• Event-day, 9 event zones  +25%</a:t>
             </a:r>
           </a:p>
           <a:p>
@@ -3789,7 +3789,7 @@
                   <a:srgbClr val="C0392B"/>
                 </a:solidFill>
               </a:rPr>
-              <a:t>• Napoli Centrale gateway  +50%</a:t>
+              <a:t>• Steepest: Centro Direzionale +74%, Race Village +45%</a:t>
             </a:r>
           </a:p>
           <a:p>
@@ -3800,7 +3800,7 @@
             </a:pPr>
             <a:r>
               <a:rPr sz="1600" b="0"/>
-              <a:t>• The race venue (Bagnoli) is over-served — 3 lines, V/C only ~0.35.</a:t>
+              <a:t>• The race venue (Bagnoli) is over-served — 3 lines, V/C only ~0.5–0.7.</a:t>
             </a:r>
           </a:p>
         </p:txBody>
@@ -3822,7 +3822,7 @@
         <p:spPr>
           <a:xfrm>
             <a:off x="5760720" y="1321435"/>
-            <a:ext cx="6126480" cy="3696718"/>
+            <a:ext cx="6126480" cy="3699463"/>
           </a:xfrm>
           <a:prstGeom prst="rect">
             <a:avLst/>
@@ -3897,7 +3897,7 @@
         <p:spPr>
           <a:xfrm>
             <a:off x="365760" y="1371600"/>
-            <a:ext cx="5394960" cy="3774252"/>
+            <a:ext cx="5394960" cy="3774251"/>
           </a:xfrm>
           <a:prstGeom prst="rect">
             <a:avLst/>
@@ -4034,7 +4034,7 @@
         <p:spPr>
           <a:xfrm>
             <a:off x="365760" y="1325880"/>
-            <a:ext cx="5394960" cy="4717221"/>
+            <a:ext cx="5394960" cy="4703326"/>
           </a:xfrm>
           <a:prstGeom prst="rect">
             <a:avLst/>
@@ -4085,7 +4085,7 @@
             </a:pPr>
             <a:r>
               <a:rPr sz="1600" b="0"/>
-              <a:t>• 73% of Campania-origin tourist demand is within a 45-min drive (mean 37 min) → Naples-centred → confirms central L1 pressure.</a:t>
+              <a:t>• 71% of Campania-origin tourist demand is within a 45-min drive (mean 41 min) → Naples-centred → confirms central L1 pressure.</a:t>
             </a:r>
           </a:p>
           <a:p>
@@ -4096,7 +4096,7 @@
             </a:pPr>
             <a:r>
               <a:rPr sz="1600" b="0"/>
-              <a:t>• ~20% comes from &gt;60 min away (Salerno/Cilento) → relies on road approaches + regional rail.</a:t>
+              <a:t>• ~21% comes from &gt;60 min away (Salerno/Cilento) → relies on road approaches + regional rail.</a:t>
             </a:r>
           </a:p>
         </p:txBody>

</xml_diff>